<commit_message>
fix: apply MSI logic, table width, and comment spacing adjustments
</commit_message>
<xml_diff>
--- a/resources/NGS_GE_report_baseline.pptx
+++ b/resources/NGS_GE_report_baseline.pptx
@@ -213,7 +213,7 @@
             <a:fld id="{B0AF433D-ACB8-475A-9DBB-3D1EBDB4B826}" type="datetimeFigureOut">
               <a:rPr lang="ko-KR" altLang="en-US" smtClean="0"/>
               <a:pPr/>
-              <a:t>2026. 2. 27.</a:t>
+              <a:t>2026. 3. 5.</a:t>
             </a:fld>
             <a:endParaRPr lang="ko-KR" altLang="en-US"/>
           </a:p>
@@ -748,7 +748,7 @@
             <a:fld id="{6DD992CD-CDBB-40CF-A1EE-0B1B8B43A805}" type="datetimeFigureOut">
               <a:rPr lang="ko-KR" altLang="en-US" smtClean="0"/>
               <a:pPr/>
-              <a:t>2026. 2. 27.</a:t>
+              <a:t>2026. 3. 5.</a:t>
             </a:fld>
             <a:endParaRPr lang="ko-KR" altLang="en-US"/>
           </a:p>
@@ -913,7 +913,7 @@
             <a:fld id="{6DD992CD-CDBB-40CF-A1EE-0B1B8B43A805}" type="datetimeFigureOut">
               <a:rPr lang="ko-KR" altLang="en-US" smtClean="0"/>
               <a:pPr/>
-              <a:t>2026. 2. 27.</a:t>
+              <a:t>2026. 3. 5.</a:t>
             </a:fld>
             <a:endParaRPr lang="ko-KR" altLang="en-US"/>
           </a:p>
@@ -1088,7 +1088,7 @@
             <a:fld id="{6DD992CD-CDBB-40CF-A1EE-0B1B8B43A805}" type="datetimeFigureOut">
               <a:rPr lang="ko-KR" altLang="en-US" smtClean="0"/>
               <a:pPr/>
-              <a:t>2026. 2. 27.</a:t>
+              <a:t>2026. 3. 5.</a:t>
             </a:fld>
             <a:endParaRPr lang="ko-KR" altLang="en-US"/>
           </a:p>
@@ -1253,7 +1253,7 @@
             <a:fld id="{6DD992CD-CDBB-40CF-A1EE-0B1B8B43A805}" type="datetimeFigureOut">
               <a:rPr lang="ko-KR" altLang="en-US" smtClean="0"/>
               <a:pPr/>
-              <a:t>2026. 2. 27.</a:t>
+              <a:t>2026. 3. 5.</a:t>
             </a:fld>
             <a:endParaRPr lang="ko-KR" altLang="en-US"/>
           </a:p>
@@ -1495,7 +1495,7 @@
             <a:fld id="{6DD992CD-CDBB-40CF-A1EE-0B1B8B43A805}" type="datetimeFigureOut">
               <a:rPr lang="ko-KR" altLang="en-US" smtClean="0"/>
               <a:pPr/>
-              <a:t>2026. 2. 27.</a:t>
+              <a:t>2026. 3. 5.</a:t>
             </a:fld>
             <a:endParaRPr lang="ko-KR" altLang="en-US"/>
           </a:p>
@@ -1777,7 +1777,7 @@
             <a:fld id="{6DD992CD-CDBB-40CF-A1EE-0B1B8B43A805}" type="datetimeFigureOut">
               <a:rPr lang="ko-KR" altLang="en-US" smtClean="0"/>
               <a:pPr/>
-              <a:t>2026. 2. 27.</a:t>
+              <a:t>2026. 3. 5.</a:t>
             </a:fld>
             <a:endParaRPr lang="ko-KR" altLang="en-US"/>
           </a:p>
@@ -2198,7 +2198,7 @@
             <a:fld id="{6DD992CD-CDBB-40CF-A1EE-0B1B8B43A805}" type="datetimeFigureOut">
               <a:rPr lang="ko-KR" altLang="en-US" smtClean="0"/>
               <a:pPr/>
-              <a:t>2026. 2. 27.</a:t>
+              <a:t>2026. 3. 5.</a:t>
             </a:fld>
             <a:endParaRPr lang="ko-KR" altLang="en-US"/>
           </a:p>
@@ -2312,7 +2312,7 @@
             <a:fld id="{6DD992CD-CDBB-40CF-A1EE-0B1B8B43A805}" type="datetimeFigureOut">
               <a:rPr lang="ko-KR" altLang="en-US" smtClean="0"/>
               <a:pPr/>
-              <a:t>2026. 2. 27.</a:t>
+              <a:t>2026. 3. 5.</a:t>
             </a:fld>
             <a:endParaRPr lang="ko-KR" altLang="en-US"/>
           </a:p>
@@ -2404,7 +2404,7 @@
             <a:fld id="{6DD992CD-CDBB-40CF-A1EE-0B1B8B43A805}" type="datetimeFigureOut">
               <a:rPr lang="ko-KR" altLang="en-US" smtClean="0"/>
               <a:pPr/>
-              <a:t>2026. 2. 27.</a:t>
+              <a:t>2026. 3. 5.</a:t>
             </a:fld>
             <a:endParaRPr lang="ko-KR" altLang="en-US"/>
           </a:p>
@@ -2676,7 +2676,7 @@
             <a:fld id="{6DD992CD-CDBB-40CF-A1EE-0B1B8B43A805}" type="datetimeFigureOut">
               <a:rPr lang="ko-KR" altLang="en-US" smtClean="0"/>
               <a:pPr/>
-              <a:t>2026. 2. 27.</a:t>
+              <a:t>2026. 3. 5.</a:t>
             </a:fld>
             <a:endParaRPr lang="ko-KR" altLang="en-US"/>
           </a:p>
@@ -2925,7 +2925,7 @@
             <a:fld id="{6DD992CD-CDBB-40CF-A1EE-0B1B8B43A805}" type="datetimeFigureOut">
               <a:rPr lang="ko-KR" altLang="en-US" smtClean="0"/>
               <a:pPr/>
-              <a:t>2026. 2. 27.</a:t>
+              <a:t>2026. 3. 5.</a:t>
             </a:fld>
             <a:endParaRPr lang="ko-KR" altLang="en-US"/>
           </a:p>
@@ -3133,7 +3133,7 @@
             <a:fld id="{6DD992CD-CDBB-40CF-A1EE-0B1B8B43A805}" type="datetimeFigureOut">
               <a:rPr lang="ko-KR" altLang="en-US" smtClean="0"/>
               <a:pPr/>
-              <a:t>2026. 2. 27.</a:t>
+              <a:t>2026. 3. 5.</a:t>
             </a:fld>
             <a:endParaRPr lang="ko-KR" altLang="en-US"/>
           </a:p>
@@ -3970,14 +3970,14 @@
           <p:nvPr>
             <p:extLst>
               <p:ext uri="{D42A27DB-BD31-4B8C-83A1-F6EECF244321}">
-                <p14:modId xmlns:p14="http://schemas.microsoft.com/office/powerpoint/2010/main" val="1634125706"/>
+                <p14:modId xmlns:p14="http://schemas.microsoft.com/office/powerpoint/2010/main" val="3291752971"/>
               </p:ext>
             </p:extLst>
           </p:nvPr>
         </p:nvGraphicFramePr>
         <p:xfrm>
           <a:off x="332656" y="3232744"/>
-          <a:ext cx="6192689" cy="547200"/>
+          <a:ext cx="6170116" cy="547200"/>
         </p:xfrm>
         <a:graphic>
           <a:graphicData uri="http://schemas.openxmlformats.org/drawingml/2006/table">
@@ -3991,21 +3991,21 @@
                     </a:ext>
                   </a:extLst>
                 </a:gridCol>
-                <a:gridCol w="1138413">
+                <a:gridCol w="1260000">
                   <a:extLst>
                     <a:ext uri="{9D8B030D-6E8A-4147-A177-3AD203B41FA5}">
                       <a16:colId xmlns:a16="http://schemas.microsoft.com/office/drawing/2014/main" val="20001"/>
                     </a:ext>
                   </a:extLst>
                 </a:gridCol>
-                <a:gridCol w="936104">
+                <a:gridCol w="864000">
                   <a:extLst>
                     <a:ext uri="{9D8B030D-6E8A-4147-A177-3AD203B41FA5}">
                       <a16:colId xmlns:a16="http://schemas.microsoft.com/office/drawing/2014/main" val="20002"/>
                     </a:ext>
                   </a:extLst>
                 </a:gridCol>
-                <a:gridCol w="504056">
+                <a:gridCol w="432000">
                   <a:extLst>
                     <a:ext uri="{9D8B030D-6E8A-4147-A177-3AD203B41FA5}">
                       <a16:colId xmlns:a16="http://schemas.microsoft.com/office/drawing/2014/main" val="20004"/>
@@ -8688,14 +8688,14 @@
           <p:nvPr>
             <p:extLst>
               <p:ext uri="{D42A27DB-BD31-4B8C-83A1-F6EECF244321}">
-                <p14:modId xmlns:p14="http://schemas.microsoft.com/office/powerpoint/2010/main" val="771264514"/>
+                <p14:modId xmlns:p14="http://schemas.microsoft.com/office/powerpoint/2010/main" val="26915927"/>
               </p:ext>
             </p:extLst>
           </p:nvPr>
         </p:nvGraphicFramePr>
         <p:xfrm>
           <a:off x="280355" y="784632"/>
-          <a:ext cx="6316998" cy="835200"/>
+          <a:ext cx="6325971" cy="547200"/>
         </p:xfrm>
         <a:graphic>
           <a:graphicData uri="http://schemas.openxmlformats.org/drawingml/2006/table">
@@ -8709,21 +8709,21 @@
                     </a:ext>
                   </a:extLst>
                 </a:gridCol>
-                <a:gridCol w="1106867">
+                <a:gridCol w="1260000">
                   <a:extLst>
                     <a:ext uri="{9D8B030D-6E8A-4147-A177-3AD203B41FA5}">
                       <a16:colId xmlns:a16="http://schemas.microsoft.com/office/drawing/2014/main" val="20001"/>
                     </a:ext>
                   </a:extLst>
                 </a:gridCol>
-                <a:gridCol w="936104">
+                <a:gridCol w="864000">
                   <a:extLst>
                     <a:ext uri="{9D8B030D-6E8A-4147-A177-3AD203B41FA5}">
                       <a16:colId xmlns:a16="http://schemas.microsoft.com/office/drawing/2014/main" val="20002"/>
                     </a:ext>
                   </a:extLst>
                 </a:gridCol>
-                <a:gridCol w="504056">
+                <a:gridCol w="432000">
                   <a:extLst>
                     <a:ext uri="{9D8B030D-6E8A-4147-A177-3AD203B41FA5}">
                       <a16:colId xmlns:a16="http://schemas.microsoft.com/office/drawing/2014/main" val="20004"/>
@@ -9425,299 +9425,6 @@
                 <a:extLst>
                   <a:ext uri="{0D108BD9-81ED-4DB2-BD59-A6C34878D82A}">
                     <a16:rowId xmlns:a16="http://schemas.microsoft.com/office/drawing/2014/main" val="10001"/>
-                  </a:ext>
-                </a:extLst>
-              </a:tr>
-              <a:tr h="288000">
-                <a:tc>
-                  <a:txBody>
-                    <a:bodyPr/>
-                    <a:lstStyle/>
-                    <a:p>
-                      <a:pPr algn="ctr" fontAlgn="ctr"/>
-                      <a:endParaRPr lang="en-US" sz="800" b="1" i="0" u="none" strike="noStrike" dirty="0">
-                        <a:solidFill>
-                          <a:srgbClr val="FF0000"/>
-                        </a:solidFill>
-                        <a:effectLst/>
-                        <a:latin typeface="+mn-ea"/>
-                        <a:ea typeface="+mn-ea"/>
-                      </a:endParaRPr>
-                    </a:p>
-                  </a:txBody>
-                  <a:tcPr marL="5625" marR="5625" marT="5625" marB="0" anchor="ctr">
-                    <a:lnL>
-                      <a:noFill/>
-                    </a:lnL>
-                    <a:lnR>
-                      <a:noFill/>
-                    </a:lnR>
-                    <a:lnT w="6350" cap="flat" cmpd="sng" algn="ctr">
-                      <a:solidFill>
-                        <a:srgbClr val="000000"/>
-                      </a:solidFill>
-                      <a:prstDash val="solid"/>
-                      <a:round/>
-                      <a:headEnd type="none" w="med" len="med"/>
-                      <a:tailEnd type="none" w="med" len="med"/>
-                    </a:lnT>
-                    <a:lnB w="6350" cap="flat" cmpd="sng" algn="ctr">
-                      <a:solidFill>
-                        <a:srgbClr val="000000"/>
-                      </a:solidFill>
-                      <a:prstDash val="solid"/>
-                      <a:round/>
-                      <a:headEnd type="none" w="med" len="med"/>
-                      <a:tailEnd type="none" w="med" len="med"/>
-                    </a:lnB>
-                    <a:solidFill>
-                      <a:srgbClr val="FFFFFF"/>
-                    </a:solidFill>
-                  </a:tcPr>
-                </a:tc>
-                <a:tc>
-                  <a:txBody>
-                    <a:bodyPr/>
-                    <a:lstStyle/>
-                    <a:p>
-                      <a:pPr algn="ctr" fontAlgn="ctr"/>
-                      <a:endParaRPr lang="en-US" sz="800" b="1" i="0" u="none" strike="noStrike" dirty="0">
-                        <a:solidFill>
-                          <a:srgbClr val="FF0000"/>
-                        </a:solidFill>
-                        <a:effectLst/>
-                        <a:latin typeface="+mn-ea"/>
-                        <a:ea typeface="+mn-ea"/>
-                      </a:endParaRPr>
-                    </a:p>
-                  </a:txBody>
-                  <a:tcPr marL="5625" marR="5625" marT="5625" marB="0" anchor="ctr">
-                    <a:lnL>
-                      <a:noFill/>
-                    </a:lnL>
-                    <a:lnR>
-                      <a:noFill/>
-                    </a:lnR>
-                    <a:lnT w="6350" cap="flat" cmpd="sng" algn="ctr">
-                      <a:solidFill>
-                        <a:srgbClr val="000000"/>
-                      </a:solidFill>
-                      <a:prstDash val="solid"/>
-                      <a:round/>
-                      <a:headEnd type="none" w="med" len="med"/>
-                      <a:tailEnd type="none" w="med" len="med"/>
-                    </a:lnT>
-                    <a:lnB w="6350" cap="flat" cmpd="sng" algn="ctr">
-                      <a:solidFill>
-                        <a:srgbClr val="000000"/>
-                      </a:solidFill>
-                      <a:prstDash val="solid"/>
-                      <a:round/>
-                      <a:headEnd type="none" w="med" len="med"/>
-                      <a:tailEnd type="none" w="med" len="med"/>
-                    </a:lnB>
-                    <a:solidFill>
-                      <a:srgbClr val="FFFFFF"/>
-                    </a:solidFill>
-                  </a:tcPr>
-                </a:tc>
-                <a:tc>
-                  <a:txBody>
-                    <a:bodyPr/>
-                    <a:lstStyle/>
-                    <a:p>
-                      <a:pPr algn="ctr" fontAlgn="ctr"/>
-                      <a:endParaRPr lang="en-US" sz="800" b="1" i="0" u="none" strike="noStrike" dirty="0">
-                        <a:solidFill>
-                          <a:srgbClr val="FF0000"/>
-                        </a:solidFill>
-                        <a:effectLst/>
-                        <a:latin typeface="+mn-ea"/>
-                        <a:ea typeface="+mn-ea"/>
-                      </a:endParaRPr>
-                    </a:p>
-                  </a:txBody>
-                  <a:tcPr marL="5625" marR="5625" marT="5625" marB="0" anchor="ctr">
-                    <a:lnL>
-                      <a:noFill/>
-                    </a:lnL>
-                    <a:lnR>
-                      <a:noFill/>
-                    </a:lnR>
-                    <a:lnT w="6350" cap="flat" cmpd="sng" algn="ctr">
-                      <a:solidFill>
-                        <a:srgbClr val="000000"/>
-                      </a:solidFill>
-                      <a:prstDash val="solid"/>
-                      <a:round/>
-                      <a:headEnd type="none" w="med" len="med"/>
-                      <a:tailEnd type="none" w="med" len="med"/>
-                    </a:lnT>
-                    <a:lnB w="6350" cap="flat" cmpd="sng" algn="ctr">
-                      <a:solidFill>
-                        <a:srgbClr val="000000"/>
-                      </a:solidFill>
-                      <a:prstDash val="solid"/>
-                      <a:round/>
-                      <a:headEnd type="none" w="med" len="med"/>
-                      <a:tailEnd type="none" w="med" len="med"/>
-                    </a:lnB>
-                  </a:tcPr>
-                </a:tc>
-                <a:tc>
-                  <a:txBody>
-                    <a:bodyPr/>
-                    <a:lstStyle/>
-                    <a:p>
-                      <a:pPr algn="ctr" fontAlgn="ctr"/>
-                      <a:endParaRPr lang="en-US" altLang="ko-KR" sz="800" b="1" i="0" u="none" strike="noStrike" dirty="0">
-                        <a:solidFill>
-                          <a:srgbClr val="FF0000"/>
-                        </a:solidFill>
-                        <a:effectLst/>
-                        <a:latin typeface="+mn-ea"/>
-                        <a:ea typeface="+mn-ea"/>
-                      </a:endParaRPr>
-                    </a:p>
-                  </a:txBody>
-                  <a:tcPr marL="5625" marR="5625" marT="5625" marB="0" anchor="ctr">
-                    <a:lnL>
-                      <a:noFill/>
-                    </a:lnL>
-                    <a:lnR>
-                      <a:noFill/>
-                    </a:lnR>
-                    <a:lnT w="6350" cap="flat" cmpd="sng" algn="ctr">
-                      <a:solidFill>
-                        <a:srgbClr val="000000"/>
-                      </a:solidFill>
-                      <a:prstDash val="solid"/>
-                      <a:round/>
-                      <a:headEnd type="none" w="med" len="med"/>
-                      <a:tailEnd type="none" w="med" len="med"/>
-                    </a:lnT>
-                    <a:lnB w="6350" cap="flat" cmpd="sng" algn="ctr">
-                      <a:solidFill>
-                        <a:srgbClr val="000000"/>
-                      </a:solidFill>
-                      <a:prstDash val="solid"/>
-                      <a:round/>
-                      <a:headEnd type="none" w="med" len="med"/>
-                      <a:tailEnd type="none" w="med" len="med"/>
-                    </a:lnB>
-                    <a:solidFill>
-                      <a:srgbClr val="FFFFFF"/>
-                    </a:solidFill>
-                  </a:tcPr>
-                </a:tc>
-                <a:tc>
-                  <a:txBody>
-                    <a:bodyPr/>
-                    <a:lstStyle/>
-                    <a:p>
-                      <a:pPr algn="ctr" fontAlgn="ctr"/>
-                      <a:endParaRPr lang="en-US" sz="800" b="1" i="0" u="none" strike="noStrike" dirty="0">
-                        <a:solidFill>
-                          <a:srgbClr val="FF0000"/>
-                        </a:solidFill>
-                        <a:effectLst/>
-                        <a:latin typeface="+mn-ea"/>
-                        <a:ea typeface="+mn-ea"/>
-                      </a:endParaRPr>
-                    </a:p>
-                  </a:txBody>
-                  <a:tcPr marL="5625" marR="5625" marT="5625" marB="0" anchor="ctr">
-                    <a:lnL>
-                      <a:noFill/>
-                    </a:lnL>
-                    <a:lnR>
-                      <a:noFill/>
-                    </a:lnR>
-                    <a:lnT w="6350" cap="flat" cmpd="sng" algn="ctr">
-                      <a:solidFill>
-                        <a:srgbClr val="000000"/>
-                      </a:solidFill>
-                      <a:prstDash val="solid"/>
-                      <a:round/>
-                      <a:headEnd type="none" w="med" len="med"/>
-                      <a:tailEnd type="none" w="med" len="med"/>
-                    </a:lnT>
-                    <a:lnB w="6350" cap="flat" cmpd="sng" algn="ctr">
-                      <a:solidFill>
-                        <a:srgbClr val="000000"/>
-                      </a:solidFill>
-                      <a:prstDash val="solid"/>
-                      <a:round/>
-                      <a:headEnd type="none" w="med" len="med"/>
-                      <a:tailEnd type="none" w="med" len="med"/>
-                    </a:lnB>
-                  </a:tcPr>
-                </a:tc>
-                <a:tc>
-                  <a:txBody>
-                    <a:bodyPr/>
-                    <a:lstStyle/>
-                    <a:p>
-                      <a:pPr marL="0" marR="0" lvl="0" indent="0" algn="ctr" defTabSz="914400" rtl="0" eaLnBrk="1" fontAlgn="ctr" latinLnBrk="1" hangingPunct="1">
-                        <a:lnSpc>
-                          <a:spcPct val="100000"/>
-                        </a:lnSpc>
-                        <a:spcBef>
-                          <a:spcPts val="0"/>
-                        </a:spcBef>
-                        <a:spcAft>
-                          <a:spcPts val="0"/>
-                        </a:spcAft>
-                        <a:buClrTx/>
-                        <a:buSzTx/>
-                        <a:buFontTx/>
-                        <a:buNone/>
-                        <a:tabLst/>
-                        <a:defRPr/>
-                      </a:pPr>
-                      <a:endParaRPr lang="en-US" altLang="ko-KR" sz="800" b="1" i="0" u="none" strike="noStrike" kern="1200" dirty="0">
-                        <a:solidFill>
-                          <a:srgbClr val="FF0000"/>
-                        </a:solidFill>
-                        <a:latin typeface="+mn-ea"/>
-                        <a:ea typeface="+mn-ea"/>
-                        <a:cs typeface="+mn-cs"/>
-                      </a:endParaRPr>
-                    </a:p>
-                  </a:txBody>
-                  <a:tcPr marL="5625" marR="5625" marT="5625" marB="0" anchor="ctr">
-                    <a:lnL>
-                      <a:noFill/>
-                    </a:lnL>
-                    <a:lnR>
-                      <a:noFill/>
-                    </a:lnR>
-                    <a:lnT w="6350" cap="flat" cmpd="sng" algn="ctr">
-                      <a:solidFill>
-                        <a:srgbClr val="000000"/>
-                      </a:solidFill>
-                      <a:prstDash val="solid"/>
-                      <a:round/>
-                      <a:headEnd type="none" w="med" len="med"/>
-                      <a:tailEnd type="none" w="med" len="med"/>
-                    </a:lnT>
-                    <a:lnB w="6350" cap="flat" cmpd="sng" algn="ctr">
-                      <a:solidFill>
-                        <a:srgbClr val="000000"/>
-                      </a:solidFill>
-                      <a:prstDash val="solid"/>
-                      <a:round/>
-                      <a:headEnd type="none" w="med" len="med"/>
-                      <a:tailEnd type="none" w="med" len="med"/>
-                    </a:lnB>
-                    <a:solidFill>
-                      <a:srgbClr val="FFFFFF"/>
-                    </a:solidFill>
-                  </a:tcPr>
-                </a:tc>
-                <a:extLst>
-                  <a:ext uri="{0D108BD9-81ED-4DB2-BD59-A6C34878D82A}">
-                    <a16:rowId xmlns:a16="http://schemas.microsoft.com/office/drawing/2014/main" val="10002"/>
                   </a:ext>
                 </a:extLst>
               </a:tr>

</xml_diff>